<commit_message>
chore: record daily YouTube research execution state
</commit_message>
<xml_diff>
--- a/reports/2026-10-08/YouTube_AI趨勢研究雷達_2026-10-08_簡報.pptx
+++ b/reports/2026-10-08/YouTube_AI趨勢研究雷達_2026-10-08_簡報.pptx
@@ -3257,37 +3257,37 @@
           <a:lstStyle/>
           <a:p>
             <a:r>
-              <a:t>1. The NEW AI Side Hustle That's Making People RICH｜47,446</a:t>
-            </a:r>
-          </a:p>
-          <a:p>
-            <a:r>
-              <a:t>2. 【新刊】AIに9割任せる株式投資は本当に使える？ChatGPT・Claudeで実際に検証してみた｜29,972</a:t>
-            </a:r>
-          </a:p>
-          <a:p>
-            <a:r>
-              <a:t>3. 【検証】AIでTikTok完全自動化｜3週間やって分かった「ガチむずい理由」｜24,965</a:t>
-            </a:r>
-          </a:p>
-          <a:p>
-            <a:r>
-              <a:t>4. 【絶対やるな】AIで作った3Dモデルを副業販売するときの落とし穴！企業に負けない個人事業の戦略を徹底解説！ #｜11,060</a:t>
-            </a:r>
-          </a:p>
-          <a:p>
-            <a:r>
-              <a:t>5. 5 Boring Claude AI Side Hustles That Pay Better Than a ｜9,266</a:t>
-            </a:r>
-          </a:p>
-          <a:p>
-            <a:r>
-              <a:t>6. 鴻海下一張王牌是機器人？AI伺服器營收狂飆　德州廠導入自動化「機器人反過來造AI」｜關我什麼事｜94要賺錢｜8,170</a:t>
-            </a:r>
-          </a:p>
-          <a:p>
-            <a:r>
-              <a:t>7. AIで稼ぐ人は、結局どんな仕事をしている？年商30億社長が今すすめる副業を本音で解説｜8,078</a:t>
+              <a:t>1. The NEW AI Side Hustle That's Making People RICH｜47,636</a:t>
+            </a:r>
+          </a:p>
+          <a:p>
+            <a:r>
+              <a:t>2. 【新刊】AIに9割任せる株式投資は本当に使える？ChatGPT・Claudeで実際に検証してみた｜30,306</a:t>
+            </a:r>
+          </a:p>
+          <a:p>
+            <a:r>
+              <a:t>3. 【検証】AIでTikTok完全自動化｜3週間やって分かった「ガチむずい理由」｜25,064</a:t>
+            </a:r>
+          </a:p>
+          <a:p>
+            <a:r>
+              <a:t>4. 【絶対やるな】AIで作った3Dモデルを副業販売するときの落とし穴！企業に負けない個人事業の戦略を徹底解説！ #｜11,504</a:t>
+            </a:r>
+          </a:p>
+          <a:p>
+            <a:r>
+              <a:t>5. 5 Boring Claude AI Side Hustles That Pay Better Than a ｜9,630</a:t>
+            </a:r>
+          </a:p>
+          <a:p>
+            <a:r>
+              <a:t>6. 鴻海下一張王牌是機器人？AI伺服器營收狂飆　德州廠導入自動化「機器人反過來造AI」｜關我什麼事｜94要賺錢｜8,431</a:t>
+            </a:r>
+          </a:p>
+          <a:p>
+            <a:r>
+              <a:t>7. AIで稼ぐ人は、結局どんな仕事をしている？年商30億社長が今すすめる副業を本音で解説｜8,050</a:t>
             </a:r>
           </a:p>
         </p:txBody>

</xml_diff>